<commit_message>
add stochastic depth; score: 0.759102;
</commit_message>
<xml_diff>
--- a/presentation/ImagesBinaryClassification.pptx
+++ b/presentation/ImagesBinaryClassification.pptx
@@ -141,7 +141,7 @@
                 </a:solidFill>
                 <a:latin typeface="Arial"/>
               </a:rPr>
-              <a:t>Training &amp; Validation Accuracy (Real Log)</a:t>
+              <a:t>Training &amp; Validation Accuracy — Full 80 Epochs</a:t>
             </a:r>
           </a:p>
         </c:rich>
@@ -225,9 +225,9 @@
           </c:marker>
           <c:cat>
             <c:multiLvlStrRef>
-              <c:f>Sheet1!$A$2:$A$14</c:f>
+              <c:f>Sheet1!$A$2:$A$16</c:f>
               <c:multiLvlStrCache>
-                <c:ptCount val="13"/>
+                <c:ptCount val="15"/>
                 <c:lvl>
                   <c:pt idx="0">
                     <c:v>E1</c:v>
@@ -236,37 +236,43 @@
                     <c:v>E5</c:v>
                   </c:pt>
                   <c:pt idx="2">
-                    <c:v>E8</c:v>
+                    <c:v>E10</c:v>
                   </c:pt>
                   <c:pt idx="3">
-                    <c:v>E11</c:v>
+                    <c:v>E15</c:v>
                   </c:pt>
                   <c:pt idx="4">
-                    <c:v>E13</c:v>
+                    <c:v>E20</c:v>
                   </c:pt>
                   <c:pt idx="5">
-                    <c:v>E17</c:v>
+                    <c:v>E25</c:v>
                   </c:pt>
                   <c:pt idx="6">
-                    <c:v>E18</c:v>
+                    <c:v>E30</c:v>
                   </c:pt>
                   <c:pt idx="7">
-                    <c:v>E22</c:v>
+                    <c:v>E35</c:v>
                   </c:pt>
                   <c:pt idx="8">
-                    <c:v>E24</c:v>
+                    <c:v>E40</c:v>
                   </c:pt>
                   <c:pt idx="9">
-                    <c:v>E27</c:v>
+                    <c:v>E45</c:v>
                   </c:pt>
                   <c:pt idx="10">
-                    <c:v>E29</c:v>
+                    <c:v>E50</c:v>
                   </c:pt>
                   <c:pt idx="11">
-                    <c:v>E33</c:v>
+                    <c:v>E55</c:v>
                   </c:pt>
                   <c:pt idx="12">
-                    <c:v>E39</c:v>
+                    <c:v>E60</c:v>
+                  </c:pt>
+                  <c:pt idx="13">
+                    <c:v>E70</c:v>
+                  </c:pt>
+                  <c:pt idx="14">
+                    <c:v>E80</c:v>
                   </c:pt>
                 </c:lvl>
               </c:multiLvlStrCache>
@@ -274,48 +280,54 @@
           </c:cat>
           <c:val>
             <c:numRef>
-              <c:f>Sheet1!$B$2:$B$14</c:f>
+              <c:f>Sheet1!$B$2:$B$16</c:f>
               <c:numCache>
                 <c:formatCode>General</c:formatCode>
-                <c:ptCount val="13"/>
+                <c:ptCount val="15"/>
                 <c:pt idx="0">
-                  <c:v>0.8068</c:v>
+                  <c:v>0.8015</c:v>
                 </c:pt>
                 <c:pt idx="1">
-                  <c:v>0.9439</c:v>
+                  <c:v>0.94</c:v>
                 </c:pt>
                 <c:pt idx="2">
-                  <c:v>0.9637</c:v>
+                  <c:v>0.9578</c:v>
                 </c:pt>
                 <c:pt idx="3">
-                  <c:v>0.9749</c:v>
+                  <c:v>0.9712</c:v>
                 </c:pt>
                 <c:pt idx="4">
-                  <c:v>0.9796</c:v>
+                  <c:v>0.9801</c:v>
                 </c:pt>
                 <c:pt idx="5">
-                  <c:v>0.9884</c:v>
+                  <c:v>0.9829</c:v>
                 </c:pt>
                 <c:pt idx="6">
-                  <c:v>0.9913</c:v>
+                  <c:v>0.9892</c:v>
                 </c:pt>
                 <c:pt idx="7">
-                  <c:v>0.9948</c:v>
+                  <c:v>0.9921</c:v>
                 </c:pt>
                 <c:pt idx="8">
-                  <c:v>0.9952</c:v>
+                  <c:v>0.9954</c:v>
                 </c:pt>
                 <c:pt idx="9">
-                  <c:v>0.9956</c:v>
+                  <c:v>0.997</c:v>
                 </c:pt>
                 <c:pt idx="10">
-                  <c:v>0.9973</c:v>
+                  <c:v>0.9979</c:v>
                 </c:pt>
                 <c:pt idx="11">
-                  <c:v>0.9975</c:v>
+                  <c:v>0.9985</c:v>
                 </c:pt>
                 <c:pt idx="12">
-                  <c:v>0.9986</c:v>
+                  <c:v>0.9988</c:v>
+                </c:pt>
+                <c:pt idx="13">
+                  <c:v>0.9993</c:v>
+                </c:pt>
+                <c:pt idx="14">
+                  <c:v>0.9993</c:v>
                 </c:pt>
               </c:numCache>
             </c:numRef>
@@ -393,9 +405,9 @@
           </c:marker>
           <c:cat>
             <c:multiLvlStrRef>
-              <c:f>Sheet1!$A$2:$A$14</c:f>
+              <c:f>Sheet1!$A$2:$A$16</c:f>
               <c:multiLvlStrCache>
-                <c:ptCount val="13"/>
+                <c:ptCount val="15"/>
                 <c:lvl>
                   <c:pt idx="0">
                     <c:v>E1</c:v>
@@ -404,37 +416,43 @@
                     <c:v>E5</c:v>
                   </c:pt>
                   <c:pt idx="2">
-                    <c:v>E8</c:v>
+                    <c:v>E10</c:v>
                   </c:pt>
                   <c:pt idx="3">
-                    <c:v>E11</c:v>
+                    <c:v>E15</c:v>
                   </c:pt>
                   <c:pt idx="4">
-                    <c:v>E13</c:v>
+                    <c:v>E20</c:v>
                   </c:pt>
                   <c:pt idx="5">
-                    <c:v>E17</c:v>
+                    <c:v>E25</c:v>
                   </c:pt>
                   <c:pt idx="6">
-                    <c:v>E18</c:v>
+                    <c:v>E30</c:v>
                   </c:pt>
                   <c:pt idx="7">
-                    <c:v>E22</c:v>
+                    <c:v>E35</c:v>
                   </c:pt>
                   <c:pt idx="8">
-                    <c:v>E24</c:v>
+                    <c:v>E40</c:v>
                   </c:pt>
                   <c:pt idx="9">
-                    <c:v>E27</c:v>
+                    <c:v>E45</c:v>
                   </c:pt>
                   <c:pt idx="10">
-                    <c:v>E29</c:v>
+                    <c:v>E50</c:v>
                   </c:pt>
                   <c:pt idx="11">
-                    <c:v>E33</c:v>
+                    <c:v>E55</c:v>
                   </c:pt>
                   <c:pt idx="12">
-                    <c:v>E39</c:v>
+                    <c:v>E60</c:v>
+                  </c:pt>
+                  <c:pt idx="13">
+                    <c:v>E70</c:v>
+                  </c:pt>
+                  <c:pt idx="14">
+                    <c:v>E80</c:v>
                   </c:pt>
                 </c:lvl>
               </c:multiLvlStrCache>
@@ -442,48 +460,54 @@
           </c:cat>
           <c:val>
             <c:numRef>
-              <c:f>Sheet1!$C$2:$C$14</c:f>
+              <c:f>Sheet1!$C$2:$C$16</c:f>
               <c:numCache>
                 <c:formatCode>General</c:formatCode>
-                <c:ptCount val="13"/>
+                <c:ptCount val="15"/>
                 <c:pt idx="0">
-                  <c:v>0.89</c:v>
+                  <c:v>0.9119</c:v>
                 </c:pt>
                 <c:pt idx="1">
-                  <c:v>0.9596</c:v>
+                  <c:v>0.9237</c:v>
                 </c:pt>
                 <c:pt idx="2">
-                  <c:v>0.9759</c:v>
+                  <c:v>0.9711</c:v>
                 </c:pt>
                 <c:pt idx="3">
-                  <c:v>0.9811</c:v>
+                  <c:v>0.9774</c:v>
                 </c:pt>
                 <c:pt idx="4">
+                  <c:v>0.9652</c:v>
+                </c:pt>
+                <c:pt idx="5">
                   <c:v>0.9911</c:v>
                 </c:pt>
-                <c:pt idx="5">
-                  <c:v>0.9944</c:v>
-                </c:pt>
                 <c:pt idx="6">
-                  <c:v>0.9967</c:v>
+                  <c:v>0.987</c:v>
                 </c:pt>
                 <c:pt idx="7">
-                  <c:v>0.997</c:v>
+                  <c:v>0.9933</c:v>
                 </c:pt>
                 <c:pt idx="8">
-                  <c:v>0.9974</c:v>
+                  <c:v>0.99</c:v>
                 </c:pt>
                 <c:pt idx="9">
-                  <c:v>0.9978</c:v>
+                  <c:v>0.9985</c:v>
                 </c:pt>
                 <c:pt idx="10">
                   <c:v>0.9993</c:v>
                 </c:pt>
                 <c:pt idx="11">
-                  <c:v>0.9993</c:v>
+                  <c:v>1</c:v>
                 </c:pt>
                 <c:pt idx="12">
-                  <c:v>0.9981</c:v>
+                  <c:v>0.9996</c:v>
+                </c:pt>
+                <c:pt idx="13">
+                  <c:v>1</c:v>
+                </c:pt>
+                <c:pt idx="14">
+                  <c:v>1</c:v>
                 </c:pt>
               </c:numCache>
             </c:numRef>
@@ -564,8 +588,8 @@
         <c:axId val="2094734552"/>
         <c:scaling>
           <c:orientation val="minMax"/>
-          <c:max val="1.005"/>
-          <c:min val="0.85"/>
+          <c:max val="1.01"/>
+          <c:min val="0.88"/>
         </c:scaling>
         <c:delete val="0"/>
         <c:axPos val="l"/>
@@ -2247,7 +2271,7 @@
               <a:buNone/>
             </a:pPr>
             <a:r>
-              <a:rPr lang="en-US" sz="1400" b="1" spc="400" kern="0" dirty="0">
+              <a:rPr lang="en-US" sz="1400" b="1" dirty="0">
                 <a:solidFill>
                   <a:srgbClr val="06B6D4"/>
                 </a:solidFill>
@@ -2697,7 +2721,7 @@
                 <a:ea typeface="Calibri" pitchFamily="34" charset="-122"/>
                 <a:cs typeface="Calibri" pitchFamily="34" charset="-120"/>
               </a:rPr>
-              <a:t>Label Smoothing</a:t>
+              <a:t>Stochastic Depth</a:t>
             </a:r>
             <a:endParaRPr lang="en-US" sz="900" dirty="0"/>
           </a:p>
@@ -3059,7 +3083,7 @@
                 <a:ea typeface="Calibri" pitchFamily="34" charset="-122"/>
                 <a:cs typeface="Calibri" pitchFamily="34" charset="-120"/>
               </a:rPr>
-              <a:t>label smoothing, cosine annealing with linear warm-up, mixed-precision training, gradient clipping</a:t>
+              <a:t>stochastic depth, cosine annealing with linear warm-up, mixed-precision training, gradient clipping</a:t>
             </a:r>
             <a:pPr indent="0" marL="0">
               <a:buNone/>
@@ -3577,7 +3601,7 @@
                 <a:ea typeface="Calibri" pitchFamily="34" charset="-122"/>
                 <a:cs typeface="Calibri" pitchFamily="34" charset="-120"/>
               </a:rPr>
-              <a:t>Label smoothing for better calibration</a:t>
+              <a:t>Stochastic Depth (DropPath) for path regularization</a:t>
             </a:r>
             <a:endParaRPr lang="en-US" sz="1100" dirty="0"/>
           </a:p>
@@ -4136,7 +4160,7 @@
                 <a:ea typeface="Calibri" pitchFamily="34" charset="-122"/>
                 <a:cs typeface="Calibri" pitchFamily="34" charset="-120"/>
               </a:rPr>
-              <a:t>Label smoothing reduces overconfidence</a:t>
+              <a:t>Hard targets (no smoothing) preserve clean binary signal</a:t>
             </a:r>
             <a:endParaRPr lang="en-US" sz="1100" dirty="0"/>
           </a:p>
@@ -6925,7 +6949,7 @@
         <p:spPr>
           <a:xfrm>
             <a:off x="228600" y="2633472"/>
-            <a:ext cx="4206240" cy="320040"/>
+            <a:ext cx="8686800" cy="320040"/>
           </a:xfrm>
           <a:prstGeom prst="rect">
             <a:avLst/>
@@ -6949,7 +6973,7 @@
                 <a:ea typeface="Calibri" pitchFamily="34" charset="-122"/>
                 <a:cs typeface="Calibri" pitchFamily="34" charset="-120"/>
               </a:rPr>
-              <a:t>CBAM Inside Each BasicBlock</a:t>
+              <a:t>Inside Each BasicBlock</a:t>
             </a:r>
             <a:endParaRPr lang="en-US" sz="1300" dirty="0"/>
           </a:p>
@@ -6964,7 +6988,7 @@
         <p:spPr>
           <a:xfrm>
             <a:off x="228600" y="3017520"/>
-            <a:ext cx="4114800" cy="1737360"/>
+            <a:ext cx="2788920" cy="1737360"/>
           </a:xfrm>
           <a:prstGeom prst="rect">
             <a:avLst/>
@@ -7053,7 +7077,7 @@
         <p:spPr>
           <a:xfrm>
             <a:off x="758952" y="3090672"/>
-            <a:ext cx="3429000" cy="347472"/>
+            <a:ext cx="2194560" cy="347472"/>
           </a:xfrm>
           <a:prstGeom prst="rect">
             <a:avLst/>
@@ -7091,8 +7115,8 @@
         </p:nvSpPr>
         <p:spPr>
           <a:xfrm>
-            <a:off x="411480" y="3493008"/>
-            <a:ext cx="3749040" cy="1188720"/>
+            <a:off x="393192" y="3493008"/>
+            <a:ext cx="2468880" cy="1188720"/>
           </a:xfrm>
           <a:prstGeom prst="rect">
             <a:avLst/>
@@ -7108,7 +7132,7 @@
               <a:buNone/>
             </a:pPr>
             <a:r>
-              <a:rPr lang="en-US" sz="1100" dirty="0">
+              <a:rPr lang="en-US" sz="1050" dirty="0">
                 <a:solidFill>
                   <a:srgbClr val="64748B"/>
                 </a:solidFill>
@@ -7118,7 +7142,7 @@
               </a:rPr>
               <a:t>Avg + Max pool → shared MLP → sigmoid gate → re-scale channels</a:t>
             </a:r>
-            <a:endParaRPr lang="en-US" sz="1100" dirty="0"/>
+            <a:endParaRPr lang="en-US" sz="1050" dirty="0"/>
           </a:p>
         </p:txBody>
       </p:sp>
@@ -7130,8 +7154,8 @@
         </p:nvSpPr>
         <p:spPr>
           <a:xfrm>
-            <a:off x="4526280" y="3017520"/>
-            <a:ext cx="4114800" cy="1737360"/>
+            <a:off x="3154680" y="3017520"/>
+            <a:ext cx="2788920" cy="1737360"/>
           </a:xfrm>
           <a:prstGeom prst="rect">
             <a:avLst/>
@@ -7155,7 +7179,7 @@
         </p:nvSpPr>
         <p:spPr>
           <a:xfrm>
-            <a:off x="4663440" y="3127248"/>
+            <a:off x="3291840" y="3127248"/>
             <a:ext cx="329184" cy="329184"/>
           </a:xfrm>
           <a:prstGeom prst="ellipse">
@@ -7180,7 +7204,7 @@
         </p:nvSpPr>
         <p:spPr>
           <a:xfrm>
-            <a:off x="4663440" y="3127248"/>
+            <a:off x="3291840" y="3127248"/>
             <a:ext cx="329184" cy="329184"/>
           </a:xfrm>
           <a:prstGeom prst="rect">
@@ -7219,8 +7243,8 @@
         </p:nvSpPr>
         <p:spPr>
           <a:xfrm>
-            <a:off x="5056632" y="3090672"/>
-            <a:ext cx="3429000" cy="347472"/>
+            <a:off x="3685032" y="3090672"/>
+            <a:ext cx="2194560" cy="347472"/>
           </a:xfrm>
           <a:prstGeom prst="rect">
             <a:avLst/>
@@ -7258,8 +7282,8 @@
         </p:nvSpPr>
         <p:spPr>
           <a:xfrm>
-            <a:off x="4709160" y="3493008"/>
-            <a:ext cx="3749040" cy="1188720"/>
+            <a:off x="3319272" y="3493008"/>
+            <a:ext cx="2468880" cy="1188720"/>
           </a:xfrm>
           <a:prstGeom prst="rect">
             <a:avLst/>
@@ -7275,7 +7299,7 @@
               <a:buNone/>
             </a:pPr>
             <a:r>
-              <a:rPr lang="en-US" sz="1100" dirty="0">
+              <a:rPr lang="en-US" sz="1050" dirty="0">
                 <a:solidFill>
                   <a:srgbClr val="64748B"/>
                 </a:solidFill>
@@ -7285,7 +7309,174 @@
               </a:rPr>
               <a:t>Channel-wise avg &amp; max concat → 7×7 Conv → sigmoid → re-scale</a:t>
             </a:r>
-            <a:endParaRPr lang="en-US" sz="1100" dirty="0"/>
+            <a:endParaRPr lang="en-US" sz="1050" dirty="0"/>
+          </a:p>
+        </p:txBody>
+      </p:sp>
+      <p:sp>
+        <p:nvSpPr>
+          <p:cNvPr id="39" name="Shape 37"/>
+          <p:cNvSpPr/>
+          <p:nvPr/>
+        </p:nvSpPr>
+        <p:spPr>
+          <a:xfrm>
+            <a:off x="6080760" y="3017520"/>
+            <a:ext cx="2788920" cy="1737360"/>
+          </a:xfrm>
+          <a:prstGeom prst="rect">
+            <a:avLst/>
+          </a:prstGeom>
+          <a:solidFill>
+            <a:srgbClr val="EFF6FF"/>
+          </a:solidFill>
+          <a:ln w="6350">
+            <a:solidFill>
+              <a:srgbClr val="E2E8F0"/>
+            </a:solidFill>
+            <a:prstDash val="solid"/>
+          </a:ln>
+        </p:spPr>
+      </p:sp>
+      <p:sp>
+        <p:nvSpPr>
+          <p:cNvPr id="40" name="Shape 38"/>
+          <p:cNvSpPr/>
+          <p:nvPr/>
+        </p:nvSpPr>
+        <p:spPr>
+          <a:xfrm>
+            <a:off x="6217920" y="3127248"/>
+            <a:ext cx="329184" cy="329184"/>
+          </a:xfrm>
+          <a:prstGeom prst="ellipse">
+            <a:avLst/>
+          </a:prstGeom>
+          <a:solidFill>
+            <a:srgbClr val="E11D48"/>
+          </a:solidFill>
+          <a:ln w="12700">
+            <a:solidFill>
+              <a:srgbClr val="E11D48"/>
+            </a:solidFill>
+            <a:prstDash val="solid"/>
+          </a:ln>
+        </p:spPr>
+      </p:sp>
+      <p:sp>
+        <p:nvSpPr>
+          <p:cNvPr id="41" name="Text 39"/>
+          <p:cNvSpPr/>
+          <p:nvPr/>
+        </p:nvSpPr>
+        <p:spPr>
+          <a:xfrm>
+            <a:off x="6217920" y="3127248"/>
+            <a:ext cx="329184" cy="329184"/>
+          </a:xfrm>
+          <a:prstGeom prst="rect">
+            <a:avLst/>
+          </a:prstGeom>
+          <a:noFill/>
+          <a:ln/>
+        </p:spPr>
+        <p:txBody>
+          <a:bodyPr wrap="square" lIns="0" tIns="0" rIns="0" bIns="0" rtlCol="0" anchor="ctr"/>
+          <a:lstStyle/>
+          <a:p>
+            <a:pPr algn="ctr" indent="0" marL="0">
+              <a:buNone/>
+            </a:pPr>
+            <a:r>
+              <a:rPr lang="en-US" sz="1200" b="1" dirty="0">
+                <a:solidFill>
+                  <a:srgbClr val="FFFFFF"/>
+                </a:solidFill>
+                <a:latin typeface="Calibri" pitchFamily="34" charset="0"/>
+                <a:ea typeface="Calibri" pitchFamily="34" charset="-122"/>
+                <a:cs typeface="Calibri" pitchFamily="34" charset="-120"/>
+              </a:rPr>
+              <a:t>3</a:t>
+            </a:r>
+            <a:endParaRPr lang="en-US" sz="1200" dirty="0"/>
+          </a:p>
+        </p:txBody>
+      </p:sp>
+      <p:sp>
+        <p:nvSpPr>
+          <p:cNvPr id="42" name="Text 40"/>
+          <p:cNvSpPr/>
+          <p:nvPr/>
+        </p:nvSpPr>
+        <p:spPr>
+          <a:xfrm>
+            <a:off x="6611112" y="3090672"/>
+            <a:ext cx="2194560" cy="347472"/>
+          </a:xfrm>
+          <a:prstGeom prst="rect">
+            <a:avLst/>
+          </a:prstGeom>
+          <a:noFill/>
+          <a:ln/>
+        </p:spPr>
+        <p:txBody>
+          <a:bodyPr wrap="square" lIns="0" tIns="0" rIns="0" bIns="0" rtlCol="0" anchor="ctr"/>
+          <a:lstStyle/>
+          <a:p>
+            <a:pPr indent="0" marL="0">
+              <a:buNone/>
+            </a:pPr>
+            <a:r>
+              <a:rPr lang="en-US" sz="1200" b="1" dirty="0">
+                <a:solidFill>
+                  <a:srgbClr val="0D1B3E"/>
+                </a:solidFill>
+                <a:latin typeface="Calibri" pitchFamily="34" charset="0"/>
+                <a:ea typeface="Calibri" pitchFamily="34" charset="-122"/>
+                <a:cs typeface="Calibri" pitchFamily="34" charset="-120"/>
+              </a:rPr>
+              <a:t>Stochastic Depth</a:t>
+            </a:r>
+            <a:endParaRPr lang="en-US" sz="1200" dirty="0"/>
+          </a:p>
+        </p:txBody>
+      </p:sp>
+      <p:sp>
+        <p:nvSpPr>
+          <p:cNvPr id="43" name="Text 41"/>
+          <p:cNvSpPr/>
+          <p:nvPr/>
+        </p:nvSpPr>
+        <p:spPr>
+          <a:xfrm>
+            <a:off x="6245352" y="3493008"/>
+            <a:ext cx="2468880" cy="1188720"/>
+          </a:xfrm>
+          <a:prstGeom prst="rect">
+            <a:avLst/>
+          </a:prstGeom>
+          <a:noFill/>
+          <a:ln/>
+        </p:spPr>
+        <p:txBody>
+          <a:bodyPr wrap="square" lIns="0" tIns="0" rIns="0" bIns="0" rtlCol="0" anchor="ctr"/>
+          <a:lstStyle/>
+          <a:p>
+            <a:pPr indent="0" marL="0">
+              <a:buNone/>
+            </a:pPr>
+            <a:r>
+              <a:rPr lang="en-US" sz="1050" dirty="0">
+                <a:solidFill>
+                  <a:srgbClr val="64748B"/>
+                </a:solidFill>
+                <a:latin typeface="Calibri" pitchFamily="34" charset="0"/>
+                <a:ea typeface="Calibri" pitchFamily="34" charset="-122"/>
+                <a:cs typeface="Calibri" pitchFamily="34" charset="-120"/>
+              </a:rPr>
+              <a:t>DropPath: linearly scaled drop rate 0 → 0.1 across 16 blocks. Active only at train time.</a:t>
+            </a:r>
+            <a:endParaRPr lang="en-US" sz="1050" dirty="0"/>
           </a:p>
         </p:txBody>
       </p:sp>
@@ -8016,7 +8207,7 @@
                 <a:ea typeface="Calibri" pitchFamily="34" charset="-122"/>
                 <a:cs typeface="Calibri" pitchFamily="34" charset="-120"/>
               </a:rPr>
-              <a:t>Regularization</a:t>
+              <a:t>Regularization + Stochastic Depth</a:t>
             </a:r>
             <a:endParaRPr lang="en-US" sz="1200" dirty="0"/>
           </a:p>
@@ -8056,7 +8247,7 @@
                 <a:ea typeface="Calibri" pitchFamily="34" charset="-122"/>
                 <a:cs typeface="Calibri" pitchFamily="34" charset="-120"/>
               </a:rPr>
-              <a:t>Dropout p = 0.3 (head) &amp; 0.15 (mid)</a:t>
+              <a:t>DropPath: linear rate 0 → 0.1 across 16 blocks</a:t>
             </a:r>
             <a:endParaRPr lang="en-US" sz="1100" dirty="0"/>
           </a:p>
@@ -8074,7 +8265,7 @@
                 <a:ea typeface="Calibri" pitchFamily="34" charset="-122"/>
                 <a:cs typeface="Calibri" pitchFamily="34" charset="-120"/>
               </a:rPr>
-              <a:t>Gradient clipping max norm = 1.0</a:t>
+              <a:t>Dropout p = 0.3 (head) &amp; 0.15 (mid)</a:t>
             </a:r>
             <a:endParaRPr lang="en-US" sz="1100" dirty="0"/>
           </a:p>
@@ -8092,7 +8283,7 @@
                 <a:ea typeface="Calibri" pitchFamily="34" charset="-122"/>
                 <a:cs typeface="Calibri" pitchFamily="34" charset="-120"/>
               </a:rPr>
-              <a:t>Mixed-precision (fp16) via AMP GradScaler</a:t>
+              <a:t>Gradient clipping max norm = 1.0</a:t>
             </a:r>
             <a:endParaRPr lang="en-US" sz="1100" dirty="0"/>
           </a:p>
@@ -8788,7 +8979,7 @@
                 <a:ea typeface="Calibri" pitchFamily="34" charset="-122"/>
                 <a:cs typeface="Calibri" pitchFamily="34" charset="-120"/>
               </a:rPr>
-              <a:t>Change in v2</a:t>
+              <a:t>Change in v3</a:t>
             </a:r>
             <a:endParaRPr lang="en-US" sz="1050" dirty="0"/>
           </a:p>
@@ -9748,7 +9939,7 @@
                 <a:ea typeface="Calibri" pitchFamily="34" charset="-122"/>
                 <a:cs typeface="Calibri" pitchFamily="34" charset="-120"/>
               </a:rPr>
-              <a:t>↑ was 0.9–1.0 (wider aug)</a:t>
+              <a:t>Unchanged</a:t>
             </a:r>
             <a:endParaRPr lang="en-US" sz="1000" dirty="0"/>
           </a:p>
@@ -9940,7 +10131,7 @@
                 <a:ea typeface="Calibri" pitchFamily="34" charset="-122"/>
                 <a:cs typeface="Calibri" pitchFamily="34" charset="-120"/>
               </a:rPr>
-              <a:t>↓ was 0.05 (disabled)</a:t>
+              <a:t>Unchanged</a:t>
             </a:r>
             <a:endParaRPr lang="en-US" sz="1000" dirty="0"/>
           </a:p>
@@ -10132,7 +10323,7 @@
                 <a:ea typeface="Calibri" pitchFamily="34" charset="-122"/>
                 <a:cs typeface="Calibri" pitchFamily="34" charset="-120"/>
               </a:rPr>
-              <a:t>↑ was 10 (more patience)</a:t>
+              <a:t>Unchanged</a:t>
             </a:r>
             <a:endParaRPr lang="en-US" sz="1000" dirty="0"/>
           </a:p>
@@ -10196,7 +10387,7 @@
                 <a:ea typeface="Calibri" pitchFamily="34" charset="-122"/>
                 <a:cs typeface="Calibri" pitchFamily="34" charset="-120"/>
               </a:rPr>
-              <a:t>LR Floor</a:t>
+              <a:t>Drop Path Rate</a:t>
             </a:r>
             <a:endParaRPr lang="en-US" sz="1000" dirty="0"/>
           </a:p>
@@ -10260,7 +10451,7 @@
                 <a:ea typeface="Calibri" pitchFamily="34" charset="-122"/>
                 <a:cs typeface="Calibri" pitchFamily="34" charset="-120"/>
               </a:rPr>
-              <a:t>None (full anneal)</a:t>
+              <a:t>0.1 (linear 0→0.1)</a:t>
             </a:r>
             <a:endParaRPr lang="en-US" sz="1000" dirty="0"/>
           </a:p>
@@ -10324,7 +10515,7 @@
                 <a:ea typeface="Calibri" pitchFamily="34" charset="-122"/>
                 <a:cs typeface="Calibri" pitchFamily="34" charset="-120"/>
               </a:rPr>
-              <a:t>↓ was 0.1% floor (removed)</a:t>
+              <a:t>✦ New — Stochastic Depth</a:t>
             </a:r>
             <a:endParaRPr lang="en-US" sz="1000" dirty="0"/>
           </a:p>
@@ -10516,7 +10707,7 @@
                 <a:ea typeface="Calibri" pitchFamily="34" charset="-122"/>
                 <a:cs typeface="Calibri" pitchFamily="34" charset="-120"/>
               </a:rPr>
-              <a:t>↑ was [0.2, 0.8] ×301</a:t>
+              <a:t>Unchanged</a:t>
             </a:r>
             <a:endParaRPr lang="en-US" sz="1000" dirty="0"/>
           </a:p>
@@ -11318,7 +11509,7 @@
                 <a:ea typeface="Calibri" pitchFamily="34" charset="-122"/>
                 <a:cs typeface="Calibri" pitchFamily="34" charset="-120"/>
               </a:rPr>
-              <a:t>99.93%</a:t>
+              <a:t>100%</a:t>
             </a:r>
             <a:endParaRPr lang="en-US" sz="3400" dirty="0"/>
           </a:p>
@@ -11357,7 +11548,7 @@
                 <a:ea typeface="Calibri" pitchFamily="34" charset="-122"/>
                 <a:cs typeface="Calibri" pitchFamily="34" charset="-120"/>
               </a:rPr>
-              <a:t>Peak Val Accuracy</a:t>
+              <a:t>Final Val Accuracy</a:t>
             </a:r>
             <a:endParaRPr lang="en-US" sz="1100" dirty="0"/>
           </a:p>
@@ -11428,7 +11619,7 @@
                 <a:ea typeface="Calibri" pitchFamily="34" charset="-122"/>
                 <a:cs typeface="Calibri" pitchFamily="34" charset="-120"/>
               </a:rPr>
-              <a:t>0.200</a:t>
+              <a:t>0.180</a:t>
             </a:r>
             <a:endParaRPr lang="en-US" sz="3400" dirty="0"/>
           </a:p>
@@ -11538,7 +11729,7 @@
                 <a:ea typeface="Calibri" pitchFamily="34" charset="-122"/>
                 <a:cs typeface="Calibri" pitchFamily="34" charset="-120"/>
               </a:rPr>
-              <a:t>0.7589</a:t>
+              <a:t>0.7591</a:t>
             </a:r>
             <a:endParaRPr lang="en-US" sz="3400" dirty="0"/>
           </a:p>
@@ -11577,7 +11768,7 @@
                 <a:ea typeface="Calibri" pitchFamily="34" charset="-122"/>
                 <a:cs typeface="Calibri" pitchFamily="34" charset="-120"/>
               </a:rPr>
-              <a:t>Public LB Score (v2)</a:t>
+              <a:t>Public LB Score (v3)</a:t>
             </a:r>
             <a:endParaRPr lang="en-US" sz="1100" dirty="0"/>
           </a:p>
@@ -11648,7 +11839,7 @@
                 <a:ea typeface="Calibri" pitchFamily="34" charset="-122"/>
                 <a:cs typeface="Calibri" pitchFamily="34" charset="-120"/>
               </a:rPr>
-              <a:t>+0.0015</a:t>
+              <a:t>+0.0003</a:t>
             </a:r>
             <a:endParaRPr lang="en-US" sz="3400" dirty="0"/>
           </a:p>
@@ -11687,7 +11878,7 @@
                 <a:ea typeface="Calibri" pitchFamily="34" charset="-122"/>
                 <a:cs typeface="Calibri" pitchFamily="34" charset="-120"/>
               </a:rPr>
-              <a:t>Score Δ vs v1</a:t>
+              <a:t>Score Δ vs v2</a:t>
             </a:r>
             <a:endParaRPr lang="en-US" sz="1100" dirty="0"/>
           </a:p>
@@ -11806,7 +11997,7 @@
                 <a:ea typeface="Calibri" pitchFamily="34" charset="-122"/>
                 <a:cs typeface="Calibri" pitchFamily="34" charset="-120"/>
               </a:rPr>
-              <a:t>v1 LB</a:t>
+              <a:t>v2 LB</a:t>
             </a:r>
             <a:endParaRPr lang="en-US" sz="1100" dirty="0"/>
           </a:p>
@@ -11845,7 +12036,7 @@
                 <a:ea typeface="Calibri" pitchFamily="34" charset="-122"/>
                 <a:cs typeface="Calibri" pitchFamily="34" charset="-120"/>
               </a:rPr>
-              <a:t>0.757356 — baseline score</a:t>
+              <a:t>0.758852 — previous best</a:t>
             </a:r>
             <a:endParaRPr lang="en-US" sz="1050" dirty="0"/>
           </a:p>
@@ -11909,7 +12100,7 @@
                 <a:ea typeface="Calibri" pitchFamily="34" charset="-122"/>
                 <a:cs typeface="Calibri" pitchFamily="34" charset="-120"/>
               </a:rPr>
-              <a:t>v2 LB</a:t>
+              <a:t>v3 LB</a:t>
             </a:r>
             <a:endParaRPr lang="en-US" sz="1100" dirty="0"/>
           </a:p>
@@ -11948,7 +12139,7 @@
                 <a:ea typeface="Calibri" pitchFamily="34" charset="-122"/>
                 <a:cs typeface="Calibri" pitchFamily="34" charset="-120"/>
               </a:rPr>
-              <a:t>0.758852 — new best (+0.15%)</a:t>
+              <a:t>0.759102 — new best (+0.025%)</a:t>
             </a:r>
             <a:endParaRPr lang="en-US" sz="1050" dirty="0"/>
           </a:p>
@@ -12012,7 +12203,7 @@
                 <a:ea typeface="Calibri" pitchFamily="34" charset="-122"/>
                 <a:cs typeface="Calibri" pitchFamily="34" charset="-120"/>
               </a:rPr>
-              <a:t>Ep 29</a:t>
+              <a:t>Ep 55</a:t>
             </a:r>
             <a:endParaRPr lang="en-US" sz="1100" dirty="0"/>
           </a:p>
@@ -12051,7 +12242,7 @@
                 <a:ea typeface="Calibri" pitchFamily="34" charset="-122"/>
                 <a:cs typeface="Calibri" pitchFamily="34" charset="-120"/>
               </a:rPr>
-              <a:t>Best val acc: 99.93% (39 ep stop)</a:t>
+              <a:t>Val first hit 100% — held to Ep 80</a:t>
             </a:r>
             <a:endParaRPr lang="en-US" sz="1050" dirty="0"/>
           </a:p>
@@ -12115,7 +12306,7 @@
                 <a:ea typeface="Calibri" pitchFamily="34" charset="-122"/>
                 <a:cs typeface="Calibri" pitchFamily="34" charset="-120"/>
               </a:rPr>
-              <a:t>t=0.20</a:t>
+              <a:t>t=0.180</a:t>
             </a:r>
             <a:endParaRPr lang="en-US" sz="1100" dirty="0"/>
           </a:p>
@@ -12154,7 +12345,7 @@
                 <a:ea typeface="Calibri" pitchFamily="34" charset="-122"/>
                 <a:cs typeface="Calibri" pitchFamily="34" charset="-120"/>
               </a:rPr>
-              <a:t>Threshold → 100% val accuracy</a:t>
+              <a:t>Threshold shifted (was 0.200 in v2)</a:t>
             </a:r>
             <a:endParaRPr lang="en-US" sz="1050" dirty="0"/>
           </a:p>
@@ -12218,7 +12409,7 @@
                 <a:ea typeface="Calibri" pitchFamily="34" charset="-122"/>
                 <a:cs typeface="Calibri" pitchFamily="34" charset="-120"/>
               </a:rPr>
-              <a:t>Key Δ</a:t>
+              <a:t>No stop</a:t>
             </a:r>
             <a:endParaRPr lang="en-US" sz="1100" dirty="0"/>
           </a:p>
@@ -12257,7 +12448,7 @@
                 <a:ea typeface="Calibri" pitchFamily="34" charset="-122"/>
                 <a:cs typeface="Calibri" pitchFamily="34" charset="-120"/>
               </a:rPr>
-              <a:t>No smoothing + full LR anneal</a:t>
+              <a:t>Full 80 eps ran — patience not hit</a:t>
             </a:r>
             <a:endParaRPr lang="en-US" sz="1050" dirty="0"/>
           </a:p>
@@ -12482,7 +12673,7 @@
                 <a:ea typeface="Calibri" pitchFamily="34" charset="-122"/>
                 <a:cs typeface="Calibri" pitchFamily="34" charset="-120"/>
               </a:rPr>
-              <a:t>Public LB: 0.758852 — up from 0.757356 (v1)</a:t>
+              <a:t>Public LB: 0.759102 — new best (up from 0.758852 in v2)</a:t>
             </a:r>
             <a:endParaRPr lang="en-US" sz="1150" dirty="0"/>
           </a:p>
@@ -12500,7 +12691,7 @@
                 <a:ea typeface="Calibri" pitchFamily="34" charset="-122"/>
                 <a:cs typeface="Calibri" pitchFamily="34" charset="-120"/>
               </a:rPr>
-              <a:t>Removing label smoothing sharpened binary signal</a:t>
+              <a:t>Stochastic Depth (DropPath, rate 0→0.1) improved generalization</a:t>
             </a:r>
             <a:endParaRPr lang="en-US" sz="1150" dirty="0"/>
           </a:p>
@@ -12518,7 +12709,7 @@
                 <a:ea typeface="Calibri" pitchFamily="34" charset="-122"/>
                 <a:cs typeface="Calibri" pitchFamily="34" charset="-120"/>
               </a:rPr>
-              <a:t>Full cosine annealing improved late-stage convergence</a:t>
+              <a:t>Ran full 80 epochs — patience-15 early stop not triggered</a:t>
             </a:r>
             <a:endParaRPr lang="en-US" sz="1150" dirty="0"/>
           </a:p>
@@ -12536,7 +12727,7 @@
                 <a:ea typeface="Calibri" pitchFamily="34" charset="-122"/>
                 <a:cs typeface="Calibri" pitchFamily="34" charset="-120"/>
               </a:rPr>
-              <a:t>Wider crop scale (0.7–1.0) added geometric diversity</a:t>
+              <a:t>Val accuracy hit 100% at epoch 55, held through epoch 80</a:t>
             </a:r>
             <a:endParaRPr lang="en-US" sz="1150" dirty="0"/>
           </a:p>
@@ -12554,7 +12745,7 @@
                 <a:ea typeface="Calibri" pitchFamily="34" charset="-122"/>
                 <a:cs typeface="Calibri" pitchFamily="34" charset="-120"/>
               </a:rPr>
-              <a:t>Patience 15 + wider threshold search stabilized boundary</a:t>
+              <a:t>Threshold shifted from 0.200 → 0.180 with DropPath active</a:t>
             </a:r>
             <a:endParaRPr lang="en-US" sz="1150" dirty="0"/>
           </a:p>

</xml_diff>